<commit_message>
docs: add app screenshots to pitch deck
</commit_message>
<xml_diff>
--- a/NightRx-Pitch-Deck.pptx
+++ b/NightRx-Pitch-Deck.pptx
@@ -5,22 +5,22 @@
     <p:sldMasterId id="2147483648" r:id="rId1"/>
   </p:sldMasterIdLst>
   <p:sldIdLst>
-    <p:sldId id="256" r:id="rId7"/>
-    <p:sldId id="257" r:id="rId8"/>
-    <p:sldId id="258" r:id="rId9"/>
-    <p:sldId id="259" r:id="rId10"/>
-    <p:sldId id="260" r:id="rId11"/>
-    <p:sldId id="261" r:id="rId12"/>
-    <p:sldId id="262" r:id="rId13"/>
-    <p:sldId id="263" r:id="rId14"/>
-    <p:sldId id="264" r:id="rId15"/>
-    <p:sldId id="265" r:id="rId16"/>
-    <p:sldId id="266" r:id="rId17"/>
-    <p:sldId id="267" r:id="rId18"/>
-    <p:sldId id="268" r:id="rId19"/>
-    <p:sldId id="269" r:id="rId20"/>
+    <p:sldId id="256" r:id="rId2"/>
+    <p:sldId id="257" r:id="rId3"/>
+    <p:sldId id="258" r:id="rId4"/>
+    <p:sldId id="259" r:id="rId5"/>
+    <p:sldId id="260" r:id="rId6"/>
+    <p:sldId id="261" r:id="rId7"/>
+    <p:sldId id="262" r:id="rId8"/>
+    <p:sldId id="263" r:id="rId9"/>
+    <p:sldId id="264" r:id="rId10"/>
+    <p:sldId id="265" r:id="rId11"/>
+    <p:sldId id="266" r:id="rId12"/>
+    <p:sldId id="267" r:id="rId13"/>
+    <p:sldId id="268" r:id="rId14"/>
+    <p:sldId id="269" r:id="rId15"/>
   </p:sldIdLst>
-  <p:sldSz cx="14630400" cy="8229600" type="screen4x3"/>
+  <p:sldSz cx="14630400" cy="8229600"/>
   <p:notesSz cx="6858000" cy="9144000"/>
   <p:defaultTextStyle>
     <a:defPPr>
@@ -117,6 +117,22 @@
       </a:defRPr>
     </a:lvl9pPr>
   </p:defaultTextStyle>
+  <p:extLst>
+    <p:ext uri="{EFAFB233-063F-42B5-8137-9DF3F51BA10A}">
+      <p15:sldGuideLst xmlns:p15="http://schemas.microsoft.com/office/powerpoint/2012/main">
+        <p15:guide id="1" orient="horz" pos="2160">
+          <p15:clr>
+            <a:srgbClr val="A4A3A4"/>
+          </p15:clr>
+        </p15:guide>
+        <p15:guide id="2" pos="2880">
+          <p15:clr>
+            <a:srgbClr val="A4A3A4"/>
+          </p15:clr>
+        </p15:guide>
+      </p15:sldGuideLst>
+    </p:ext>
+  </p:extLst>
 </p:presentation>
 </file>
 
@@ -158,10 +174,9 @@
           <a:lstStyle/>
           <a:p>
             <a:r>
-              <a:rPr lang="en-US" smtClean="0"/>
+              <a:rPr lang="en-US"/>
               <a:t>Click to edit Master title style</a:t>
             </a:r>
-            <a:endParaRPr lang="en-US"/>
           </a:p>
         </p:txBody>
       </p:sp>
@@ -277,10 +292,9 @@
           </a:lstStyle>
           <a:p>
             <a:r>
-              <a:rPr lang="en-US" smtClean="0"/>
+              <a:rPr lang="en-US"/>
               <a:t>Click to edit Master subtitle style</a:t>
             </a:r>
-            <a:endParaRPr lang="en-US"/>
           </a:p>
         </p:txBody>
       </p:sp>
@@ -301,7 +315,7 @@
           <a:p>
             <a:fld id="{5BCAD085-E8A6-8845-BD4E-CB4CCA059FC4}" type="datetimeFigureOut">
               <a:rPr lang="en-US" smtClean="0"/>
-              <a:t>1/27/13</a:t>
+              <a:t>4/4/2026</a:t>
             </a:fld>
             <a:endParaRPr lang="en-US"/>
           </a:p>
@@ -395,10 +409,9 @@
           <a:lstStyle/>
           <a:p>
             <a:r>
-              <a:rPr lang="en-US" smtClean="0"/>
+              <a:rPr lang="en-US"/>
               <a:t>Click to edit Master title style</a:t>
             </a:r>
-            <a:endParaRPr lang="en-US"/>
           </a:p>
         </p:txBody>
       </p:sp>
@@ -419,38 +432,37 @@
           <a:p>
             <a:pPr lvl="0"/>
             <a:r>
-              <a:rPr lang="en-US" smtClean="0"/>
+              <a:rPr lang="en-US"/>
               <a:t>Click to edit Master text styles</a:t>
             </a:r>
           </a:p>
           <a:p>
             <a:pPr lvl="1"/>
             <a:r>
-              <a:rPr lang="en-US" smtClean="0"/>
+              <a:rPr lang="en-US"/>
               <a:t>Second level</a:t>
             </a:r>
           </a:p>
           <a:p>
             <a:pPr lvl="2"/>
             <a:r>
-              <a:rPr lang="en-US" smtClean="0"/>
+              <a:rPr lang="en-US"/>
               <a:t>Third level</a:t>
             </a:r>
           </a:p>
           <a:p>
             <a:pPr lvl="3"/>
             <a:r>
-              <a:rPr lang="en-US" smtClean="0"/>
+              <a:rPr lang="en-US"/>
               <a:t>Fourth level</a:t>
             </a:r>
           </a:p>
           <a:p>
             <a:pPr lvl="4"/>
             <a:r>
-              <a:rPr lang="en-US" smtClean="0"/>
+              <a:rPr lang="en-US"/>
               <a:t>Fifth level</a:t>
             </a:r>
-            <a:endParaRPr lang="en-US"/>
           </a:p>
         </p:txBody>
       </p:sp>
@@ -471,7 +483,7 @@
           <a:p>
             <a:fld id="{5BCAD085-E8A6-8845-BD4E-CB4CCA059FC4}" type="datetimeFigureOut">
               <a:rPr lang="en-US" smtClean="0"/>
-              <a:t>1/27/13</a:t>
+              <a:t>4/4/2026</a:t>
             </a:fld>
             <a:endParaRPr lang="en-US"/>
           </a:p>
@@ -570,10 +582,9 @@
           <a:lstStyle/>
           <a:p>
             <a:r>
-              <a:rPr lang="en-US" smtClean="0"/>
+              <a:rPr lang="en-US"/>
               <a:t>Click to edit Master title style</a:t>
             </a:r>
-            <a:endParaRPr lang="en-US"/>
           </a:p>
         </p:txBody>
       </p:sp>
@@ -599,38 +610,37 @@
           <a:p>
             <a:pPr lvl="0"/>
             <a:r>
-              <a:rPr lang="en-US" smtClean="0"/>
+              <a:rPr lang="en-US"/>
               <a:t>Click to edit Master text styles</a:t>
             </a:r>
           </a:p>
           <a:p>
             <a:pPr lvl="1"/>
             <a:r>
-              <a:rPr lang="en-US" smtClean="0"/>
+              <a:rPr lang="en-US"/>
               <a:t>Second level</a:t>
             </a:r>
           </a:p>
           <a:p>
             <a:pPr lvl="2"/>
             <a:r>
-              <a:rPr lang="en-US" smtClean="0"/>
+              <a:rPr lang="en-US"/>
               <a:t>Third level</a:t>
             </a:r>
           </a:p>
           <a:p>
             <a:pPr lvl="3"/>
             <a:r>
-              <a:rPr lang="en-US" smtClean="0"/>
+              <a:rPr lang="en-US"/>
               <a:t>Fourth level</a:t>
             </a:r>
           </a:p>
           <a:p>
             <a:pPr lvl="4"/>
             <a:r>
-              <a:rPr lang="en-US" smtClean="0"/>
+              <a:rPr lang="en-US"/>
               <a:t>Fifth level</a:t>
             </a:r>
-            <a:endParaRPr lang="en-US"/>
           </a:p>
         </p:txBody>
       </p:sp>
@@ -651,7 +661,7 @@
           <a:p>
             <a:fld id="{5BCAD085-E8A6-8845-BD4E-CB4CCA059FC4}" type="datetimeFigureOut">
               <a:rPr lang="en-US" smtClean="0"/>
-              <a:t>1/27/13</a:t>
+              <a:t>4/4/2026</a:t>
             </a:fld>
             <a:endParaRPr lang="en-US"/>
           </a:p>
@@ -745,10 +755,9 @@
           <a:lstStyle/>
           <a:p>
             <a:r>
-              <a:rPr lang="en-US" smtClean="0"/>
+              <a:rPr lang="en-US"/>
               <a:t>Click to edit Master title style</a:t>
             </a:r>
-            <a:endParaRPr lang="en-US"/>
           </a:p>
         </p:txBody>
       </p:sp>
@@ -769,38 +778,37 @@
           <a:p>
             <a:pPr lvl="0"/>
             <a:r>
-              <a:rPr lang="en-US" smtClean="0"/>
+              <a:rPr lang="en-US"/>
               <a:t>Click to edit Master text styles</a:t>
             </a:r>
           </a:p>
           <a:p>
             <a:pPr lvl="1"/>
             <a:r>
-              <a:rPr lang="en-US" smtClean="0"/>
+              <a:rPr lang="en-US"/>
               <a:t>Second level</a:t>
             </a:r>
           </a:p>
           <a:p>
             <a:pPr lvl="2"/>
             <a:r>
-              <a:rPr lang="en-US" smtClean="0"/>
+              <a:rPr lang="en-US"/>
               <a:t>Third level</a:t>
             </a:r>
           </a:p>
           <a:p>
             <a:pPr lvl="3"/>
             <a:r>
-              <a:rPr lang="en-US" smtClean="0"/>
+              <a:rPr lang="en-US"/>
               <a:t>Fourth level</a:t>
             </a:r>
           </a:p>
           <a:p>
             <a:pPr lvl="4"/>
             <a:r>
-              <a:rPr lang="en-US" smtClean="0"/>
+              <a:rPr lang="en-US"/>
               <a:t>Fifth level</a:t>
             </a:r>
-            <a:endParaRPr lang="en-US"/>
           </a:p>
         </p:txBody>
       </p:sp>
@@ -821,7 +829,7 @@
           <a:p>
             <a:fld id="{5BCAD085-E8A6-8845-BD4E-CB4CCA059FC4}" type="datetimeFigureOut">
               <a:rPr lang="en-US" smtClean="0"/>
-              <a:t>1/27/13</a:t>
+              <a:t>4/4/2026</a:t>
             </a:fld>
             <a:endParaRPr lang="en-US"/>
           </a:p>
@@ -924,10 +932,9 @@
           </a:lstStyle>
           <a:p>
             <a:r>
-              <a:rPr lang="en-US" smtClean="0"/>
+              <a:rPr lang="en-US"/>
               <a:t>Click to edit Master title style</a:t>
             </a:r>
-            <a:endParaRPr lang="en-US"/>
           </a:p>
         </p:txBody>
       </p:sp>
@@ -1044,7 +1051,7 @@
           <a:p>
             <a:pPr lvl="0"/>
             <a:r>
-              <a:rPr lang="en-US" smtClean="0"/>
+              <a:rPr lang="en-US"/>
               <a:t>Click to edit Master text styles</a:t>
             </a:r>
           </a:p>
@@ -1067,7 +1074,7 @@
           <a:p>
             <a:fld id="{5BCAD085-E8A6-8845-BD4E-CB4CCA059FC4}" type="datetimeFigureOut">
               <a:rPr lang="en-US" smtClean="0"/>
-              <a:t>1/27/13</a:t>
+              <a:t>4/4/2026</a:t>
             </a:fld>
             <a:endParaRPr lang="en-US"/>
           </a:p>
@@ -1161,10 +1168,9 @@
           <a:lstStyle/>
           <a:p>
             <a:r>
-              <a:rPr lang="en-US" smtClean="0"/>
+              <a:rPr lang="en-US"/>
               <a:t>Click to edit Master title style</a:t>
             </a:r>
-            <a:endParaRPr lang="en-US"/>
           </a:p>
         </p:txBody>
       </p:sp>
@@ -1218,38 +1224,37 @@
           <a:p>
             <a:pPr lvl="0"/>
             <a:r>
-              <a:rPr lang="en-US" smtClean="0"/>
+              <a:rPr lang="en-US"/>
               <a:t>Click to edit Master text styles</a:t>
             </a:r>
           </a:p>
           <a:p>
             <a:pPr lvl="1"/>
             <a:r>
-              <a:rPr lang="en-US" smtClean="0"/>
+              <a:rPr lang="en-US"/>
               <a:t>Second level</a:t>
             </a:r>
           </a:p>
           <a:p>
             <a:pPr lvl="2"/>
             <a:r>
-              <a:rPr lang="en-US" smtClean="0"/>
+              <a:rPr lang="en-US"/>
               <a:t>Third level</a:t>
             </a:r>
           </a:p>
           <a:p>
             <a:pPr lvl="3"/>
             <a:r>
-              <a:rPr lang="en-US" smtClean="0"/>
+              <a:rPr lang="en-US"/>
               <a:t>Fourth level</a:t>
             </a:r>
           </a:p>
           <a:p>
             <a:pPr lvl="4"/>
             <a:r>
-              <a:rPr lang="en-US" smtClean="0"/>
+              <a:rPr lang="en-US"/>
               <a:t>Fifth level</a:t>
             </a:r>
-            <a:endParaRPr lang="en-US"/>
           </a:p>
         </p:txBody>
       </p:sp>
@@ -1303,38 +1308,37 @@
           <a:p>
             <a:pPr lvl="0"/>
             <a:r>
-              <a:rPr lang="en-US" smtClean="0"/>
+              <a:rPr lang="en-US"/>
               <a:t>Click to edit Master text styles</a:t>
             </a:r>
           </a:p>
           <a:p>
             <a:pPr lvl="1"/>
             <a:r>
-              <a:rPr lang="en-US" smtClean="0"/>
+              <a:rPr lang="en-US"/>
               <a:t>Second level</a:t>
             </a:r>
           </a:p>
           <a:p>
             <a:pPr lvl="2"/>
             <a:r>
-              <a:rPr lang="en-US" smtClean="0"/>
+              <a:rPr lang="en-US"/>
               <a:t>Third level</a:t>
             </a:r>
           </a:p>
           <a:p>
             <a:pPr lvl="3"/>
             <a:r>
-              <a:rPr lang="en-US" smtClean="0"/>
+              <a:rPr lang="en-US"/>
               <a:t>Fourth level</a:t>
             </a:r>
           </a:p>
           <a:p>
             <a:pPr lvl="4"/>
             <a:r>
-              <a:rPr lang="en-US" smtClean="0"/>
+              <a:rPr lang="en-US"/>
               <a:t>Fifth level</a:t>
             </a:r>
-            <a:endParaRPr lang="en-US"/>
           </a:p>
         </p:txBody>
       </p:sp>
@@ -1355,7 +1359,7 @@
           <a:p>
             <a:fld id="{5BCAD085-E8A6-8845-BD4E-CB4CCA059FC4}" type="datetimeFigureOut">
               <a:rPr lang="en-US" smtClean="0"/>
-              <a:t>1/27/13</a:t>
+              <a:t>4/4/2026</a:t>
             </a:fld>
             <a:endParaRPr lang="en-US"/>
           </a:p>
@@ -1453,10 +1457,9 @@
           </a:lstStyle>
           <a:p>
             <a:r>
-              <a:rPr lang="en-US" smtClean="0"/>
+              <a:rPr lang="en-US"/>
               <a:t>Click to edit Master title style</a:t>
             </a:r>
-            <a:endParaRPr lang="en-US"/>
           </a:p>
         </p:txBody>
       </p:sp>
@@ -1519,7 +1522,7 @@
           <a:p>
             <a:pPr lvl="0"/>
             <a:r>
-              <a:rPr lang="en-US" smtClean="0"/>
+              <a:rPr lang="en-US"/>
               <a:t>Click to edit Master text styles</a:t>
             </a:r>
           </a:p>
@@ -1575,38 +1578,37 @@
           <a:p>
             <a:pPr lvl="0"/>
             <a:r>
-              <a:rPr lang="en-US" smtClean="0"/>
+              <a:rPr lang="en-US"/>
               <a:t>Click to edit Master text styles</a:t>
             </a:r>
           </a:p>
           <a:p>
             <a:pPr lvl="1"/>
             <a:r>
-              <a:rPr lang="en-US" smtClean="0"/>
+              <a:rPr lang="en-US"/>
               <a:t>Second level</a:t>
             </a:r>
           </a:p>
           <a:p>
             <a:pPr lvl="2"/>
             <a:r>
-              <a:rPr lang="en-US" smtClean="0"/>
+              <a:rPr lang="en-US"/>
               <a:t>Third level</a:t>
             </a:r>
           </a:p>
           <a:p>
             <a:pPr lvl="3"/>
             <a:r>
-              <a:rPr lang="en-US" smtClean="0"/>
+              <a:rPr lang="en-US"/>
               <a:t>Fourth level</a:t>
             </a:r>
           </a:p>
           <a:p>
             <a:pPr lvl="4"/>
             <a:r>
-              <a:rPr lang="en-US" smtClean="0"/>
+              <a:rPr lang="en-US"/>
               <a:t>Fifth level</a:t>
             </a:r>
-            <a:endParaRPr lang="en-US"/>
           </a:p>
         </p:txBody>
       </p:sp>
@@ -1669,7 +1671,7 @@
           <a:p>
             <a:pPr lvl="0"/>
             <a:r>
-              <a:rPr lang="en-US" smtClean="0"/>
+              <a:rPr lang="en-US"/>
               <a:t>Click to edit Master text styles</a:t>
             </a:r>
           </a:p>
@@ -1725,38 +1727,37 @@
           <a:p>
             <a:pPr lvl="0"/>
             <a:r>
-              <a:rPr lang="en-US" smtClean="0"/>
+              <a:rPr lang="en-US"/>
               <a:t>Click to edit Master text styles</a:t>
             </a:r>
           </a:p>
           <a:p>
             <a:pPr lvl="1"/>
             <a:r>
-              <a:rPr lang="en-US" smtClean="0"/>
+              <a:rPr lang="en-US"/>
               <a:t>Second level</a:t>
             </a:r>
           </a:p>
           <a:p>
             <a:pPr lvl="2"/>
             <a:r>
-              <a:rPr lang="en-US" smtClean="0"/>
+              <a:rPr lang="en-US"/>
               <a:t>Third level</a:t>
             </a:r>
           </a:p>
           <a:p>
             <a:pPr lvl="3"/>
             <a:r>
-              <a:rPr lang="en-US" smtClean="0"/>
+              <a:rPr lang="en-US"/>
               <a:t>Fourth level</a:t>
             </a:r>
           </a:p>
           <a:p>
             <a:pPr lvl="4"/>
             <a:r>
-              <a:rPr lang="en-US" smtClean="0"/>
+              <a:rPr lang="en-US"/>
               <a:t>Fifth level</a:t>
             </a:r>
-            <a:endParaRPr lang="en-US"/>
           </a:p>
         </p:txBody>
       </p:sp>
@@ -1777,7 +1778,7 @@
           <a:p>
             <a:fld id="{5BCAD085-E8A6-8845-BD4E-CB4CCA059FC4}" type="datetimeFigureOut">
               <a:rPr lang="en-US" smtClean="0"/>
-              <a:t>1/27/13</a:t>
+              <a:t>4/4/2026</a:t>
             </a:fld>
             <a:endParaRPr lang="en-US"/>
           </a:p>
@@ -1871,10 +1872,9 @@
           <a:lstStyle/>
           <a:p>
             <a:r>
-              <a:rPr lang="en-US" smtClean="0"/>
+              <a:rPr lang="en-US"/>
               <a:t>Click to edit Master title style</a:t>
             </a:r>
-            <a:endParaRPr lang="en-US"/>
           </a:p>
         </p:txBody>
       </p:sp>
@@ -1895,7 +1895,7 @@
           <a:p>
             <a:fld id="{5BCAD085-E8A6-8845-BD4E-CB4CCA059FC4}" type="datetimeFigureOut">
               <a:rPr lang="en-US" smtClean="0"/>
-              <a:t>1/27/13</a:t>
+              <a:t>4/4/2026</a:t>
             </a:fld>
             <a:endParaRPr lang="en-US"/>
           </a:p>
@@ -1990,7 +1990,7 @@
           <a:p>
             <a:fld id="{5BCAD085-E8A6-8845-BD4E-CB4CCA059FC4}" type="datetimeFigureOut">
               <a:rPr lang="en-US" smtClean="0"/>
-              <a:t>1/27/13</a:t>
+              <a:t>4/4/2026</a:t>
             </a:fld>
             <a:endParaRPr lang="en-US"/>
           </a:p>
@@ -2093,10 +2093,9 @@
           </a:lstStyle>
           <a:p>
             <a:r>
-              <a:rPr lang="en-US" smtClean="0"/>
+              <a:rPr lang="en-US"/>
               <a:t>Click to edit Master title style</a:t>
             </a:r>
-            <a:endParaRPr lang="en-US"/>
           </a:p>
         </p:txBody>
       </p:sp>
@@ -2150,38 +2149,37 @@
           <a:p>
             <a:pPr lvl="0"/>
             <a:r>
-              <a:rPr lang="en-US" smtClean="0"/>
+              <a:rPr lang="en-US"/>
               <a:t>Click to edit Master text styles</a:t>
             </a:r>
           </a:p>
           <a:p>
             <a:pPr lvl="1"/>
             <a:r>
-              <a:rPr lang="en-US" smtClean="0"/>
+              <a:rPr lang="en-US"/>
               <a:t>Second level</a:t>
             </a:r>
           </a:p>
           <a:p>
             <a:pPr lvl="2"/>
             <a:r>
-              <a:rPr lang="en-US" smtClean="0"/>
+              <a:rPr lang="en-US"/>
               <a:t>Third level</a:t>
             </a:r>
           </a:p>
           <a:p>
             <a:pPr lvl="3"/>
             <a:r>
-              <a:rPr lang="en-US" smtClean="0"/>
+              <a:rPr lang="en-US"/>
               <a:t>Fourth level</a:t>
             </a:r>
           </a:p>
           <a:p>
             <a:pPr lvl="4"/>
             <a:r>
-              <a:rPr lang="en-US" smtClean="0"/>
+              <a:rPr lang="en-US"/>
               <a:t>Fifth level</a:t>
             </a:r>
-            <a:endParaRPr lang="en-US"/>
           </a:p>
         </p:txBody>
       </p:sp>
@@ -2244,7 +2242,7 @@
           <a:p>
             <a:pPr lvl="0"/>
             <a:r>
-              <a:rPr lang="en-US" smtClean="0"/>
+              <a:rPr lang="en-US"/>
               <a:t>Click to edit Master text styles</a:t>
             </a:r>
           </a:p>
@@ -2267,7 +2265,7 @@
           <a:p>
             <a:fld id="{5BCAD085-E8A6-8845-BD4E-CB4CCA059FC4}" type="datetimeFigureOut">
               <a:rPr lang="en-US" smtClean="0"/>
-              <a:t>1/27/13</a:t>
+              <a:t>4/4/2026</a:t>
             </a:fld>
             <a:endParaRPr lang="en-US"/>
           </a:p>
@@ -2370,10 +2368,9 @@
           </a:lstStyle>
           <a:p>
             <a:r>
-              <a:rPr lang="en-US" smtClean="0"/>
+              <a:rPr lang="en-US"/>
               <a:t>Click to edit Master title style</a:t>
             </a:r>
-            <a:endParaRPr lang="en-US"/>
           </a:p>
         </p:txBody>
       </p:sp>
@@ -2497,7 +2494,7 @@
           <a:p>
             <a:pPr lvl="0"/>
             <a:r>
-              <a:rPr lang="en-US" smtClean="0"/>
+              <a:rPr lang="en-US"/>
               <a:t>Click to edit Master text styles</a:t>
             </a:r>
           </a:p>
@@ -2520,7 +2517,7 @@
           <a:p>
             <a:fld id="{5BCAD085-E8A6-8845-BD4E-CB4CCA059FC4}" type="datetimeFigureOut">
               <a:rPr lang="en-US" smtClean="0"/>
-              <a:t>1/27/13</a:t>
+              <a:t>4/4/2026</a:t>
             </a:fld>
             <a:endParaRPr lang="en-US"/>
           </a:p>
@@ -2629,10 +2626,9 @@
           <a:lstStyle/>
           <a:p>
             <a:r>
-              <a:rPr lang="en-US" smtClean="0"/>
+              <a:rPr lang="en-US"/>
               <a:t>Click to edit Master title style</a:t>
             </a:r>
-            <a:endParaRPr lang="en-US"/>
           </a:p>
         </p:txBody>
       </p:sp>
@@ -2663,38 +2659,37 @@
           <a:p>
             <a:pPr lvl="0"/>
             <a:r>
-              <a:rPr lang="en-US" smtClean="0"/>
+              <a:rPr lang="en-US"/>
               <a:t>Click to edit Master text styles</a:t>
             </a:r>
           </a:p>
           <a:p>
             <a:pPr lvl="1"/>
             <a:r>
-              <a:rPr lang="en-US" smtClean="0"/>
+              <a:rPr lang="en-US"/>
               <a:t>Second level</a:t>
             </a:r>
           </a:p>
           <a:p>
             <a:pPr lvl="2"/>
             <a:r>
-              <a:rPr lang="en-US" smtClean="0"/>
+              <a:rPr lang="en-US"/>
               <a:t>Third level</a:t>
             </a:r>
           </a:p>
           <a:p>
             <a:pPr lvl="3"/>
             <a:r>
-              <a:rPr lang="en-US" smtClean="0"/>
+              <a:rPr lang="en-US"/>
               <a:t>Fourth level</a:t>
             </a:r>
           </a:p>
           <a:p>
             <a:pPr lvl="4"/>
             <a:r>
-              <a:rPr lang="en-US" smtClean="0"/>
+              <a:rPr lang="en-US"/>
               <a:t>Fifth level</a:t>
             </a:r>
-            <a:endParaRPr lang="en-US"/>
           </a:p>
         </p:txBody>
       </p:sp>
@@ -2733,7 +2728,7 @@
           <a:p>
             <a:fld id="{5BCAD085-E8A6-8845-BD4E-CB4CCA059FC4}" type="datetimeFigureOut">
               <a:rPr lang="en-US" smtClean="0"/>
-              <a:t>1/27/13</a:t>
+              <a:t>4/4/2026</a:t>
             </a:fld>
             <a:endParaRPr lang="en-US"/>
           </a:p>
@@ -3092,7 +3087,7 @@
 </file>
 
 <file path=ppt/slides/slide1.xml><?xml version="1.0" encoding="utf-8"?>
-<p:sld xmlns:a="http://schemas.openxmlformats.org/drawingml/2006/main" xmlns:p="http://schemas.openxmlformats.org/presentationml/2006/main" xmlns:r="http://schemas.openxmlformats.org/officeDocument/2006/relationships">
+<p:sld xmlns:a="http://schemas.openxmlformats.org/drawingml/2006/main" xmlns:r="http://schemas.openxmlformats.org/officeDocument/2006/relationships" xmlns:p="http://schemas.openxmlformats.org/presentationml/2006/main">
   <p:cSld>
     <p:bg>
       <p:bgPr>
@@ -3108,7 +3103,14 @@
         <p:cNvGrpSpPr/>
         <p:nvPr/>
       </p:nvGrpSpPr>
-      <p:grpSpPr/>
+      <p:grpSpPr>
+        <a:xfrm>
+          <a:off x="0" y="0"/>
+          <a:ext cx="0" cy="0"/>
+          <a:chOff x="0" y="0"/>
+          <a:chExt cx="0" cy="0"/>
+        </a:xfrm>
+      </p:grpSpPr>
       <p:sp>
         <p:nvSpPr>
           <p:cNvPr id="2" name="Rectangle 1"/>
@@ -3149,6 +3151,7 @@
           <a:lstStyle/>
           <a:p>
             <a:pPr algn="ctr"/>
+            <a:endParaRPr/>
           </a:p>
         </p:txBody>
       </p:sp>
@@ -3192,6 +3195,7 @@
           <a:lstStyle/>
           <a:p>
             <a:pPr algn="ctr"/>
+            <a:endParaRPr/>
           </a:p>
         </p:txBody>
       </p:sp>
@@ -3307,6 +3311,7 @@
           <a:lstStyle/>
           <a:p>
             <a:pPr algn="ctr"/>
+            <a:endParaRPr/>
           </a:p>
         </p:txBody>
       </p:sp>
@@ -3386,6 +3391,7 @@
           <a:lstStyle/>
           <a:p>
             <a:pPr algn="ctr"/>
+            <a:endParaRPr/>
           </a:p>
         </p:txBody>
       </p:sp>
@@ -3465,6 +3471,7 @@
           <a:lstStyle/>
           <a:p>
             <a:pPr algn="ctr"/>
+            <a:endParaRPr/>
           </a:p>
         </p:txBody>
       </p:sp>
@@ -3513,7 +3520,7 @@
 </file>
 
 <file path=ppt/slides/slide10.xml><?xml version="1.0" encoding="utf-8"?>
-<p:sld xmlns:a="http://schemas.openxmlformats.org/drawingml/2006/main" xmlns:p="http://schemas.openxmlformats.org/presentationml/2006/main" xmlns:r="http://schemas.openxmlformats.org/officeDocument/2006/relationships">
+<p:sld xmlns:a="http://schemas.openxmlformats.org/drawingml/2006/main" xmlns:r="http://schemas.openxmlformats.org/officeDocument/2006/relationships" xmlns:p="http://schemas.openxmlformats.org/presentationml/2006/main">
   <p:cSld>
     <p:bg>
       <p:bgPr>
@@ -3529,7 +3536,14 @@
         <p:cNvGrpSpPr/>
         <p:nvPr/>
       </p:nvGrpSpPr>
-      <p:grpSpPr/>
+      <p:grpSpPr>
+        <a:xfrm>
+          <a:off x="0" y="0"/>
+          <a:ext cx="0" cy="0"/>
+          <a:chOff x="0" y="0"/>
+          <a:chExt cx="0" cy="0"/>
+        </a:xfrm>
+      </p:grpSpPr>
       <p:sp>
         <p:nvSpPr>
           <p:cNvPr id="2" name="TextBox 1"/>
@@ -3642,6 +3656,7 @@
           <a:lstStyle/>
           <a:p>
             <a:pPr algn="ctr"/>
+            <a:endParaRPr/>
           </a:p>
         </p:txBody>
       </p:sp>
@@ -3685,6 +3700,7 @@
           <a:lstStyle/>
           <a:p>
             <a:pPr algn="ctr"/>
+            <a:endParaRPr/>
           </a:p>
         </p:txBody>
       </p:sp>
@@ -4052,6 +4068,7 @@
           <a:lstStyle/>
           <a:p>
             <a:pPr algn="ctr"/>
+            <a:endParaRPr/>
           </a:p>
         </p:txBody>
       </p:sp>
@@ -4095,6 +4112,7 @@
           <a:lstStyle/>
           <a:p>
             <a:pPr algn="ctr"/>
+            <a:endParaRPr/>
           </a:p>
         </p:txBody>
       </p:sp>
@@ -4431,7 +4449,7 @@
 </file>
 
 <file path=ppt/slides/slide11.xml><?xml version="1.0" encoding="utf-8"?>
-<p:sld xmlns:a="http://schemas.openxmlformats.org/drawingml/2006/main" xmlns:p="http://schemas.openxmlformats.org/presentationml/2006/main" xmlns:r="http://schemas.openxmlformats.org/officeDocument/2006/relationships">
+<p:sld xmlns:a="http://schemas.openxmlformats.org/drawingml/2006/main" xmlns:r="http://schemas.openxmlformats.org/officeDocument/2006/relationships" xmlns:p="http://schemas.openxmlformats.org/presentationml/2006/main">
   <p:cSld>
     <p:bg>
       <p:bgPr>
@@ -4447,7 +4465,14 @@
         <p:cNvGrpSpPr/>
         <p:nvPr/>
       </p:nvGrpSpPr>
-      <p:grpSpPr/>
+      <p:grpSpPr>
+        <a:xfrm>
+          <a:off x="0" y="0"/>
+          <a:ext cx="0" cy="0"/>
+          <a:chOff x="0" y="0"/>
+          <a:chExt cx="0" cy="0"/>
+        </a:xfrm>
+      </p:grpSpPr>
       <p:sp>
         <p:nvSpPr>
           <p:cNvPr id="2" name="TextBox 1"/>
@@ -4524,6 +4549,7 @@
           <a:lstStyle/>
           <a:p>
             <a:pPr algn="ctr"/>
+            <a:endParaRPr/>
           </a:p>
         </p:txBody>
       </p:sp>
@@ -4603,6 +4629,7 @@
           <a:lstStyle/>
           <a:p>
             <a:pPr algn="ctr"/>
+            <a:endParaRPr/>
           </a:p>
         </p:txBody>
       </p:sp>
@@ -4758,6 +4785,7 @@
           <a:lstStyle/>
           <a:p>
             <a:pPr algn="ctr"/>
+            <a:endParaRPr/>
           </a:p>
         </p:txBody>
       </p:sp>
@@ -4913,6 +4941,7 @@
           <a:lstStyle/>
           <a:p>
             <a:pPr algn="ctr"/>
+            <a:endParaRPr/>
           </a:p>
         </p:txBody>
       </p:sp>
@@ -5068,6 +5097,7 @@
           <a:lstStyle/>
           <a:p>
             <a:pPr algn="ctr"/>
+            <a:endParaRPr/>
           </a:p>
         </p:txBody>
       </p:sp>
@@ -5192,7 +5222,7 @@
 </file>
 
 <file path=ppt/slides/slide12.xml><?xml version="1.0" encoding="utf-8"?>
-<p:sld xmlns:a="http://schemas.openxmlformats.org/drawingml/2006/main" xmlns:p="http://schemas.openxmlformats.org/presentationml/2006/main" xmlns:r="http://schemas.openxmlformats.org/officeDocument/2006/relationships">
+<p:sld xmlns:a="http://schemas.openxmlformats.org/drawingml/2006/main" xmlns:r="http://schemas.openxmlformats.org/officeDocument/2006/relationships" xmlns:p="http://schemas.openxmlformats.org/presentationml/2006/main">
   <p:cSld>
     <p:bg>
       <p:bgPr>
@@ -5208,7 +5238,14 @@
         <p:cNvGrpSpPr/>
         <p:nvPr/>
       </p:nvGrpSpPr>
-      <p:grpSpPr/>
+      <p:grpSpPr>
+        <a:xfrm>
+          <a:off x="0" y="0"/>
+          <a:ext cx="0" cy="0"/>
+          <a:chOff x="0" y="0"/>
+          <a:chExt cx="0" cy="0"/>
+        </a:xfrm>
+      </p:grpSpPr>
       <p:sp>
         <p:nvSpPr>
           <p:cNvPr id="2" name="TextBox 1"/>
@@ -5321,6 +5358,7 @@
           <a:lstStyle/>
           <a:p>
             <a:pPr algn="ctr"/>
+            <a:endParaRPr/>
           </a:p>
         </p:txBody>
       </p:sp>
@@ -5400,6 +5438,7 @@
           <a:lstStyle/>
           <a:p>
             <a:pPr algn="ctr"/>
+            <a:endParaRPr/>
           </a:p>
         </p:txBody>
       </p:sp>
@@ -5483,6 +5522,7 @@
           <a:lstStyle/>
           <a:p>
             <a:pPr algn="ctr"/>
+            <a:endParaRPr/>
           </a:p>
         </p:txBody>
       </p:sp>
@@ -5562,6 +5602,7 @@
           <a:lstStyle/>
           <a:p>
             <a:pPr algn="ctr"/>
+            <a:endParaRPr/>
           </a:p>
         </p:txBody>
       </p:sp>
@@ -5645,6 +5686,7 @@
           <a:lstStyle/>
           <a:p>
             <a:pPr algn="ctr"/>
+            <a:endParaRPr/>
           </a:p>
         </p:txBody>
       </p:sp>
@@ -5724,6 +5766,7 @@
           <a:lstStyle/>
           <a:p>
             <a:pPr algn="ctr"/>
+            <a:endParaRPr/>
           </a:p>
         </p:txBody>
       </p:sp>
@@ -5807,6 +5850,7 @@
           <a:lstStyle/>
           <a:p>
             <a:pPr algn="ctr"/>
+            <a:endParaRPr/>
           </a:p>
         </p:txBody>
       </p:sp>
@@ -5886,6 +5930,7 @@
           <a:lstStyle/>
           <a:p>
             <a:pPr algn="ctr"/>
+            <a:endParaRPr/>
           </a:p>
         </p:txBody>
       </p:sp>
@@ -5969,6 +6014,7 @@
           <a:lstStyle/>
           <a:p>
             <a:pPr algn="ctr"/>
+            <a:endParaRPr/>
           </a:p>
         </p:txBody>
       </p:sp>
@@ -6057,7 +6103,7 @@
 </file>
 
 <file path=ppt/slides/slide13.xml><?xml version="1.0" encoding="utf-8"?>
-<p:sld xmlns:a="http://schemas.openxmlformats.org/drawingml/2006/main" xmlns:p="http://schemas.openxmlformats.org/presentationml/2006/main" xmlns:r="http://schemas.openxmlformats.org/officeDocument/2006/relationships">
+<p:sld xmlns:a="http://schemas.openxmlformats.org/drawingml/2006/main" xmlns:r="http://schemas.openxmlformats.org/officeDocument/2006/relationships" xmlns:p="http://schemas.openxmlformats.org/presentationml/2006/main">
   <p:cSld>
     <p:bg>
       <p:bgPr>
@@ -6073,7 +6119,14 @@
         <p:cNvGrpSpPr/>
         <p:nvPr/>
       </p:nvGrpSpPr>
-      <p:grpSpPr/>
+      <p:grpSpPr>
+        <a:xfrm>
+          <a:off x="0" y="0"/>
+          <a:ext cx="0" cy="0"/>
+          <a:chOff x="0" y="0"/>
+          <a:chExt cx="0" cy="0"/>
+        </a:xfrm>
+      </p:grpSpPr>
       <p:sp>
         <p:nvSpPr>
           <p:cNvPr id="2" name="TextBox 1"/>
@@ -6186,6 +6239,7 @@
           <a:lstStyle/>
           <a:p>
             <a:pPr algn="ctr"/>
+            <a:endParaRPr/>
           </a:p>
         </p:txBody>
       </p:sp>
@@ -6301,6 +6355,7 @@
           <a:lstStyle/>
           <a:p>
             <a:pPr algn="ctr"/>
+            <a:endParaRPr/>
           </a:p>
         </p:txBody>
       </p:sp>
@@ -6416,6 +6471,7 @@
           <a:lstStyle/>
           <a:p>
             <a:pPr algn="ctr"/>
+            <a:endParaRPr/>
           </a:p>
         </p:txBody>
       </p:sp>
@@ -6531,6 +6587,7 @@
           <a:lstStyle/>
           <a:p>
             <a:pPr algn="ctr"/>
+            <a:endParaRPr/>
           </a:p>
         </p:txBody>
       </p:sp>
@@ -6646,6 +6703,7 @@
           <a:lstStyle/>
           <a:p>
             <a:pPr algn="ctr"/>
+            <a:endParaRPr/>
           </a:p>
         </p:txBody>
       </p:sp>
@@ -6761,6 +6819,7 @@
           <a:lstStyle/>
           <a:p>
             <a:pPr algn="ctr"/>
+            <a:endParaRPr/>
           </a:p>
         </p:txBody>
       </p:sp>
@@ -6881,7 +6940,7 @@
 </file>
 
 <file path=ppt/slides/slide14.xml><?xml version="1.0" encoding="utf-8"?>
-<p:sld xmlns:a="http://schemas.openxmlformats.org/drawingml/2006/main" xmlns:p="http://schemas.openxmlformats.org/presentationml/2006/main" xmlns:r="http://schemas.openxmlformats.org/officeDocument/2006/relationships">
+<p:sld xmlns:a="http://schemas.openxmlformats.org/drawingml/2006/main" xmlns:r="http://schemas.openxmlformats.org/officeDocument/2006/relationships" xmlns:p="http://schemas.openxmlformats.org/presentationml/2006/main">
   <p:cSld>
     <p:bg>
       <p:bgPr>
@@ -6897,7 +6956,14 @@
         <p:cNvGrpSpPr/>
         <p:nvPr/>
       </p:nvGrpSpPr>
-      <p:grpSpPr/>
+      <p:grpSpPr>
+        <a:xfrm>
+          <a:off x="0" y="0"/>
+          <a:ext cx="0" cy="0"/>
+          <a:chOff x="0" y="0"/>
+          <a:chExt cx="0" cy="0"/>
+        </a:xfrm>
+      </p:grpSpPr>
       <p:sp>
         <p:nvSpPr>
           <p:cNvPr id="2" name="Rounded Rectangle 1"/>
@@ -6938,6 +7004,7 @@
           <a:lstStyle/>
           <a:p>
             <a:pPr algn="ctr"/>
+            <a:endParaRPr/>
           </a:p>
         </p:txBody>
       </p:sp>
@@ -7057,6 +7124,7 @@
           <a:lstStyle/>
           <a:p>
             <a:pPr algn="ctr"/>
+            <a:endParaRPr/>
           </a:p>
         </p:txBody>
       </p:sp>
@@ -7100,6 +7168,7 @@
           <a:lstStyle/>
           <a:p>
             <a:pPr algn="ctr"/>
+            <a:endParaRPr/>
           </a:p>
         </p:txBody>
       </p:sp>
@@ -7251,6 +7320,7 @@
           <a:lstStyle/>
           <a:p>
             <a:pPr algn="ctr"/>
+            <a:endParaRPr/>
           </a:p>
         </p:txBody>
       </p:sp>
@@ -7402,6 +7472,7 @@
           <a:lstStyle/>
           <a:p>
             <a:pPr algn="ctr"/>
+            <a:endParaRPr/>
           </a:p>
         </p:txBody>
       </p:sp>
@@ -7558,7 +7629,7 @@
 </file>
 
 <file path=ppt/slides/slide2.xml><?xml version="1.0" encoding="utf-8"?>
-<p:sld xmlns:a="http://schemas.openxmlformats.org/drawingml/2006/main" xmlns:p="http://schemas.openxmlformats.org/presentationml/2006/main" xmlns:r="http://schemas.openxmlformats.org/officeDocument/2006/relationships">
+<p:sld xmlns:a="http://schemas.openxmlformats.org/drawingml/2006/main" xmlns:r="http://schemas.openxmlformats.org/officeDocument/2006/relationships" xmlns:p="http://schemas.openxmlformats.org/presentationml/2006/main">
   <p:cSld>
     <p:bg>
       <p:bgPr>
@@ -7574,7 +7645,14 @@
         <p:cNvGrpSpPr/>
         <p:nvPr/>
       </p:nvGrpSpPr>
-      <p:grpSpPr/>
+      <p:grpSpPr>
+        <a:xfrm>
+          <a:off x="0" y="0"/>
+          <a:ext cx="0" cy="0"/>
+          <a:chOff x="0" y="0"/>
+          <a:chExt cx="0" cy="0"/>
+        </a:xfrm>
+      </p:grpSpPr>
       <p:sp>
         <p:nvSpPr>
           <p:cNvPr id="2" name="TextBox 1"/>
@@ -7727,6 +7805,7 @@
           <a:lstStyle/>
           <a:p>
             <a:pPr algn="ctr"/>
+            <a:endParaRPr/>
           </a:p>
         </p:txBody>
       </p:sp>
@@ -7842,6 +7921,7 @@
           <a:lstStyle/>
           <a:p>
             <a:pPr algn="ctr"/>
+            <a:endParaRPr/>
           </a:p>
         </p:txBody>
       </p:sp>
@@ -7957,6 +8037,7 @@
           <a:lstStyle/>
           <a:p>
             <a:pPr algn="ctr"/>
+            <a:endParaRPr/>
           </a:p>
         </p:txBody>
       </p:sp>
@@ -8041,7 +8122,7 @@
 </file>
 
 <file path=ppt/slides/slide3.xml><?xml version="1.0" encoding="utf-8"?>
-<p:sld xmlns:a="http://schemas.openxmlformats.org/drawingml/2006/main" xmlns:p="http://schemas.openxmlformats.org/presentationml/2006/main" xmlns:r="http://schemas.openxmlformats.org/officeDocument/2006/relationships">
+<p:sld xmlns:a="http://schemas.openxmlformats.org/drawingml/2006/main" xmlns:r="http://schemas.openxmlformats.org/officeDocument/2006/relationships" xmlns:p="http://schemas.openxmlformats.org/presentationml/2006/main">
   <p:cSld>
     <p:bg>
       <p:bgPr>
@@ -8057,7 +8138,14 @@
         <p:cNvGrpSpPr/>
         <p:nvPr/>
       </p:nvGrpSpPr>
-      <p:grpSpPr/>
+      <p:grpSpPr>
+        <a:xfrm>
+          <a:off x="0" y="0"/>
+          <a:ext cx="0" cy="0"/>
+          <a:chOff x="0" y="0"/>
+          <a:chExt cx="0" cy="0"/>
+        </a:xfrm>
+      </p:grpSpPr>
       <p:sp>
         <p:nvSpPr>
           <p:cNvPr id="2" name="TextBox 1"/>
@@ -8138,6 +8226,7 @@
           <a:lstStyle/>
           <a:p>
             <a:pPr algn="ctr"/>
+            <a:endParaRPr/>
           </a:p>
         </p:txBody>
       </p:sp>
@@ -8194,7 +8283,7 @@
 </file>
 
 <file path=ppt/slides/slide4.xml><?xml version="1.0" encoding="utf-8"?>
-<p:sld xmlns:a="http://schemas.openxmlformats.org/drawingml/2006/main" xmlns:p="http://schemas.openxmlformats.org/presentationml/2006/main" xmlns:r="http://schemas.openxmlformats.org/officeDocument/2006/relationships">
+<p:sld xmlns:a="http://schemas.openxmlformats.org/drawingml/2006/main" xmlns:r="http://schemas.openxmlformats.org/officeDocument/2006/relationships" xmlns:p="http://schemas.openxmlformats.org/presentationml/2006/main">
   <p:cSld>
     <p:bg>
       <p:bgPr>
@@ -8210,7 +8299,14 @@
         <p:cNvGrpSpPr/>
         <p:nvPr/>
       </p:nvGrpSpPr>
-      <p:grpSpPr/>
+      <p:grpSpPr>
+        <a:xfrm>
+          <a:off x="0" y="0"/>
+          <a:ext cx="0" cy="0"/>
+          <a:chOff x="0" y="0"/>
+          <a:chExt cx="0" cy="0"/>
+        </a:xfrm>
+      </p:grpSpPr>
       <p:sp>
         <p:nvSpPr>
           <p:cNvPr id="2" name="TextBox 1"/>
@@ -8323,6 +8419,7 @@
           <a:lstStyle/>
           <a:p>
             <a:pPr algn="ctr"/>
+            <a:endParaRPr/>
           </a:p>
         </p:txBody>
       </p:sp>
@@ -8438,6 +8535,7 @@
           <a:lstStyle/>
           <a:p>
             <a:pPr algn="ctr"/>
+            <a:endParaRPr/>
           </a:p>
         </p:txBody>
       </p:sp>
@@ -8565,6 +8663,7 @@
           <a:lstStyle/>
           <a:p>
             <a:pPr algn="ctr"/>
+            <a:endParaRPr/>
           </a:p>
         </p:txBody>
       </p:sp>
@@ -8680,6 +8779,7 @@
           <a:lstStyle/>
           <a:p>
             <a:pPr algn="ctr"/>
+            <a:endParaRPr/>
           </a:p>
         </p:txBody>
       </p:sp>
@@ -8807,6 +8907,7 @@
           <a:lstStyle/>
           <a:p>
             <a:pPr algn="ctr"/>
+            <a:endParaRPr/>
           </a:p>
         </p:txBody>
       </p:sp>
@@ -8922,6 +9023,7 @@
           <a:lstStyle/>
           <a:p>
             <a:pPr algn="ctr"/>
+            <a:endParaRPr/>
           </a:p>
         </p:txBody>
       </p:sp>
@@ -8982,7 +9084,7 @@
 </file>
 
 <file path=ppt/slides/slide5.xml><?xml version="1.0" encoding="utf-8"?>
-<p:sld xmlns:a="http://schemas.openxmlformats.org/drawingml/2006/main" xmlns:p="http://schemas.openxmlformats.org/presentationml/2006/main" xmlns:r="http://schemas.openxmlformats.org/officeDocument/2006/relationships">
+<p:sld xmlns:a="http://schemas.openxmlformats.org/drawingml/2006/main" xmlns:r="http://schemas.openxmlformats.org/officeDocument/2006/relationships" xmlns:p="http://schemas.openxmlformats.org/presentationml/2006/main">
   <p:cSld>
     <p:bg>
       <p:bgPr>
@@ -8998,7 +9100,14 @@
         <p:cNvGrpSpPr/>
         <p:nvPr/>
       </p:nvGrpSpPr>
-      <p:grpSpPr/>
+      <p:grpSpPr>
+        <a:xfrm>
+          <a:off x="0" y="0"/>
+          <a:ext cx="0" cy="0"/>
+          <a:chOff x="0" y="0"/>
+          <a:chExt cx="0" cy="0"/>
+        </a:xfrm>
+      </p:grpSpPr>
       <p:sp>
         <p:nvSpPr>
           <p:cNvPr id="2" name="TextBox 1"/>
@@ -9298,45 +9407,40 @@
           <a:lstStyle/>
           <a:p>
             <a:pPr algn="ctr"/>
-          </a:p>
-        </p:txBody>
-      </p:sp>
-      <p:sp>
-        <p:nvSpPr>
-          <p:cNvPr id="10" name="TextBox 9"/>
-          <p:cNvSpPr txBox="1"/>
-          <p:nvPr/>
-        </p:nvSpPr>
-        <p:spPr>
-          <a:xfrm>
-            <a:off x="6858000" y="3886200"/>
-            <a:ext cx="6858000" cy="457200"/>
-          </a:xfrm>
-          <a:prstGeom prst="rect">
-            <a:avLst/>
-          </a:prstGeom>
-          <a:noFill/>
-        </p:spPr>
-        <p:txBody>
-          <a:bodyPr wrap="square">
-            <a:spAutoFit/>
-          </a:bodyPr>
-          <a:lstStyle/>
-          <a:p>
-            <a:pPr algn="ctr">
-              <a:defRPr sz="1400" b="0">
-                <a:solidFill>
-                  <a:srgbClr val="5A5A70"/>
-                </a:solidFill>
-                <a:latin typeface="Calibri"/>
-              </a:defRPr>
-            </a:pPr>
-            <a:r>
-              <a:t>[Clinic Dashboard Screenshot]</a:t>
-            </a:r>
-          </a:p>
-        </p:txBody>
-      </p:sp>
+            <a:endParaRPr/>
+          </a:p>
+        </p:txBody>
+      </p:sp>
+      <p:pic>
+        <p:nvPicPr>
+          <p:cNvPr id="12" name="Picture 11">
+            <a:extLst>
+              <a:ext uri="{FF2B5EF4-FFF2-40B4-BE49-F238E27FC236}">
+                <a16:creationId xmlns:a16="http://schemas.microsoft.com/office/drawing/2014/main" id="{FCA9FFF0-371C-B274-D019-9741CC6081D4}"/>
+              </a:ext>
+            </a:extLst>
+          </p:cNvPr>
+          <p:cNvPicPr>
+            <a:picLocks noChangeAspect="1"/>
+          </p:cNvPicPr>
+          <p:nvPr/>
+        </p:nvPicPr>
+        <p:blipFill>
+          <a:blip r:embed="rId2"/>
+          <a:stretch>
+            <a:fillRect/>
+          </a:stretch>
+        </p:blipFill>
+        <p:spPr>
+          <a:xfrm>
+            <a:off x="6858000" y="1760514"/>
+            <a:ext cx="6818692" cy="4772488"/>
+          </a:xfrm>
+          <a:prstGeom prst="rect">
+            <a:avLst/>
+          </a:prstGeom>
+        </p:spPr>
+      </p:pic>
     </p:spTree>
   </p:cSld>
   <p:clrMapOvr>
@@ -9346,7 +9450,7 @@
 </file>
 
 <file path=ppt/slides/slide6.xml><?xml version="1.0" encoding="utf-8"?>
-<p:sld xmlns:a="http://schemas.openxmlformats.org/drawingml/2006/main" xmlns:p="http://schemas.openxmlformats.org/presentationml/2006/main" xmlns:r="http://schemas.openxmlformats.org/officeDocument/2006/relationships">
+<p:sld xmlns:a="http://schemas.openxmlformats.org/drawingml/2006/main" xmlns:r="http://schemas.openxmlformats.org/officeDocument/2006/relationships" xmlns:p="http://schemas.openxmlformats.org/presentationml/2006/main">
   <p:cSld>
     <p:bg>
       <p:bgPr>
@@ -9362,7 +9466,14 @@
         <p:cNvGrpSpPr/>
         <p:nvPr/>
       </p:nvGrpSpPr>
-      <p:grpSpPr/>
+      <p:grpSpPr>
+        <a:xfrm>
+          <a:off x="0" y="0"/>
+          <a:ext cx="0" cy="0"/>
+          <a:chOff x="0" y="0"/>
+          <a:chExt cx="0" cy="0"/>
+        </a:xfrm>
+      </p:grpSpPr>
       <p:sp>
         <p:nvSpPr>
           <p:cNvPr id="2" name="TextBox 1"/>
@@ -9579,42 +9690,6 @@
             </a:pPr>
             <a:r>
               <a:t>✓  Local ZK proof generation</a:t>
-            </a:r>
-          </a:p>
-        </p:txBody>
-      </p:sp>
-      <p:sp>
-        <p:nvSpPr>
-          <p:cNvPr id="8" name="TextBox 7"/>
-          <p:cNvSpPr txBox="1"/>
-          <p:nvPr/>
-        </p:nvSpPr>
-        <p:spPr>
-          <a:xfrm>
-            <a:off x="1371600" y="4389120"/>
-            <a:ext cx="4572000" cy="365760"/>
-          </a:xfrm>
-          <a:prstGeom prst="rect">
-            <a:avLst/>
-          </a:prstGeom>
-          <a:noFill/>
-        </p:spPr>
-        <p:txBody>
-          <a:bodyPr wrap="square">
-            <a:spAutoFit/>
-          </a:bodyPr>
-          <a:lstStyle/>
-          <a:p>
-            <a:pPr algn="l">
-              <a:defRPr sz="1500" b="0">
-                <a:solidFill>
-                  <a:srgbClr val="6EE7B7"/>
-                </a:solidFill>
-                <a:latin typeface="Calibri"/>
-              </a:defRPr>
-            </a:pPr>
-            <a:r>
-              <a:t>✓  Privacy shield animation</a:t>
             </a:r>
           </a:p>
         </p:txBody>
@@ -9662,6 +9737,7 @@
           <a:lstStyle/>
           <a:p>
             <a:pPr algn="ctr"/>
+            <a:endParaRPr/>
           </a:p>
         </p:txBody>
       </p:sp>
@@ -9701,6 +9777,36 @@
           </a:p>
         </p:txBody>
       </p:sp>
+      <p:pic>
+        <p:nvPicPr>
+          <p:cNvPr id="12" name="Picture 11">
+            <a:extLst>
+              <a:ext uri="{FF2B5EF4-FFF2-40B4-BE49-F238E27FC236}">
+                <a16:creationId xmlns:a16="http://schemas.microsoft.com/office/drawing/2014/main" id="{7F1C8DAE-2FF5-9BEA-ACDE-1B2ADBD7DDCF}"/>
+              </a:ext>
+            </a:extLst>
+          </p:cNvPr>
+          <p:cNvPicPr>
+            <a:picLocks noChangeAspect="1"/>
+          </p:cNvPicPr>
+          <p:nvPr/>
+        </p:nvPicPr>
+        <p:blipFill>
+          <a:blip r:embed="rId2"/>
+          <a:stretch>
+            <a:fillRect/>
+          </a:stretch>
+        </p:blipFill>
+        <p:spPr>
+          <a:xfrm>
+            <a:off x="6857999" y="1997901"/>
+            <a:ext cx="6858001" cy="4463143"/>
+          </a:xfrm>
+          <a:prstGeom prst="rect">
+            <a:avLst/>
+          </a:prstGeom>
+        </p:spPr>
+      </p:pic>
     </p:spTree>
   </p:cSld>
   <p:clrMapOvr>
@@ -9710,7 +9816,7 @@
 </file>
 
 <file path=ppt/slides/slide7.xml><?xml version="1.0" encoding="utf-8"?>
-<p:sld xmlns:a="http://schemas.openxmlformats.org/drawingml/2006/main" xmlns:p="http://schemas.openxmlformats.org/presentationml/2006/main" xmlns:r="http://schemas.openxmlformats.org/officeDocument/2006/relationships">
+<p:sld xmlns:a="http://schemas.openxmlformats.org/drawingml/2006/main" xmlns:r="http://schemas.openxmlformats.org/officeDocument/2006/relationships" xmlns:p="http://schemas.openxmlformats.org/presentationml/2006/main">
   <p:cSld>
     <p:bg>
       <p:bgPr>
@@ -9726,7 +9832,14 @@
         <p:cNvGrpSpPr/>
         <p:nvPr/>
       </p:nvGrpSpPr>
-      <p:grpSpPr/>
+      <p:grpSpPr>
+        <a:xfrm>
+          <a:off x="0" y="0"/>
+          <a:ext cx="0" cy="0"/>
+          <a:chOff x="0" y="0"/>
+          <a:chExt cx="0" cy="0"/>
+        </a:xfrm>
+      </p:grpSpPr>
       <p:sp>
         <p:nvSpPr>
           <p:cNvPr id="2" name="TextBox 1"/>
@@ -10026,6 +10139,7 @@
           <a:lstStyle/>
           <a:p>
             <a:pPr algn="ctr"/>
+            <a:endParaRPr/>
           </a:p>
         </p:txBody>
       </p:sp>
@@ -10065,6 +10179,36 @@
           </a:p>
         </p:txBody>
       </p:sp>
+      <p:pic>
+        <p:nvPicPr>
+          <p:cNvPr id="14" name="Picture 13">
+            <a:extLst>
+              <a:ext uri="{FF2B5EF4-FFF2-40B4-BE49-F238E27FC236}">
+                <a16:creationId xmlns:a16="http://schemas.microsoft.com/office/drawing/2014/main" id="{BF754D1E-DB93-CDF2-DF3E-E95CD95D80A0}"/>
+              </a:ext>
+            </a:extLst>
+          </p:cNvPr>
+          <p:cNvPicPr>
+            <a:picLocks noChangeAspect="1"/>
+          </p:cNvPicPr>
+          <p:nvPr/>
+        </p:nvPicPr>
+        <p:blipFill>
+          <a:blip r:embed="rId2"/>
+          <a:stretch>
+            <a:fillRect/>
+          </a:stretch>
+        </p:blipFill>
+        <p:spPr>
+          <a:xfrm>
+            <a:off x="6807622" y="1511766"/>
+            <a:ext cx="6908378" cy="5164456"/>
+          </a:xfrm>
+          <a:prstGeom prst="rect">
+            <a:avLst/>
+          </a:prstGeom>
+        </p:spPr>
+      </p:pic>
     </p:spTree>
   </p:cSld>
   <p:clrMapOvr>
@@ -10074,7 +10218,7 @@
 </file>
 
 <file path=ppt/slides/slide8.xml><?xml version="1.0" encoding="utf-8"?>
-<p:sld xmlns:a="http://schemas.openxmlformats.org/drawingml/2006/main" xmlns:p="http://schemas.openxmlformats.org/presentationml/2006/main" xmlns:r="http://schemas.openxmlformats.org/officeDocument/2006/relationships">
+<p:sld xmlns:a="http://schemas.openxmlformats.org/drawingml/2006/main" xmlns:r="http://schemas.openxmlformats.org/officeDocument/2006/relationships" xmlns:p="http://schemas.openxmlformats.org/presentationml/2006/main">
   <p:cSld>
     <p:bg>
       <p:bgPr>
@@ -10090,7 +10234,14 @@
         <p:cNvGrpSpPr/>
         <p:nvPr/>
       </p:nvGrpSpPr>
-      <p:grpSpPr/>
+      <p:grpSpPr>
+        <a:xfrm>
+          <a:off x="0" y="0"/>
+          <a:ext cx="0" cy="0"/>
+          <a:chOff x="0" y="0"/>
+          <a:chExt cx="0" cy="0"/>
+        </a:xfrm>
+      </p:grpSpPr>
       <p:sp>
         <p:nvSpPr>
           <p:cNvPr id="2" name="TextBox 1"/>
@@ -10171,7 +10322,7 @@
         </p:nvSpPr>
         <p:spPr>
           <a:xfrm>
-            <a:off x="1371600" y="2560320"/>
+            <a:off x="1371600" y="2011680"/>
             <a:ext cx="11887200" cy="1463040"/>
           </a:xfrm>
           <a:prstGeom prst="roundRect">
@@ -10203,6 +10354,7 @@
           <a:lstStyle/>
           <a:p>
             <a:pPr algn="ctr"/>
+            <a:endParaRPr/>
           </a:p>
         </p:txBody>
       </p:sp>
@@ -10214,7 +10366,7 @@
         </p:nvSpPr>
         <p:spPr>
           <a:xfrm>
-            <a:off x="1371600" y="2560320"/>
+            <a:off x="1371600" y="2011680"/>
             <a:ext cx="54864" cy="1463040"/>
           </a:xfrm>
           <a:prstGeom prst="rect">
@@ -10246,6 +10398,7 @@
           <a:lstStyle/>
           <a:p>
             <a:pPr algn="ctr"/>
+            <a:endParaRPr/>
           </a:p>
         </p:txBody>
       </p:sp>
@@ -10257,7 +10410,7 @@
         </p:nvSpPr>
         <p:spPr>
           <a:xfrm>
-            <a:off x="1828800" y="2743200"/>
+            <a:off x="1828800" y="2194560"/>
             <a:ext cx="4572000" cy="457200"/>
           </a:xfrm>
           <a:prstGeom prst="rect">
@@ -10293,7 +10446,7 @@
         </p:nvSpPr>
         <p:spPr>
           <a:xfrm>
-            <a:off x="1828800" y="3200400"/>
+            <a:off x="1828800" y="2651760"/>
             <a:ext cx="10058400" cy="640080"/>
           </a:xfrm>
           <a:prstGeom prst="rect">
@@ -10333,7 +10486,7 @@
         </p:nvSpPr>
         <p:spPr>
           <a:xfrm>
-            <a:off x="1371600" y="4297679"/>
+            <a:off x="1371600" y="3749039"/>
             <a:ext cx="11887200" cy="1463040"/>
           </a:xfrm>
           <a:prstGeom prst="roundRect">
@@ -10365,6 +10518,7 @@
           <a:lstStyle/>
           <a:p>
             <a:pPr algn="ctr"/>
+            <a:endParaRPr/>
           </a:p>
         </p:txBody>
       </p:sp>
@@ -10376,7 +10530,7 @@
         </p:nvSpPr>
         <p:spPr>
           <a:xfrm>
-            <a:off x="1371600" y="4297679"/>
+            <a:off x="1371600" y="3749039"/>
             <a:ext cx="54864" cy="1463040"/>
           </a:xfrm>
           <a:prstGeom prst="rect">
@@ -10408,6 +10562,7 @@
           <a:lstStyle/>
           <a:p>
             <a:pPr algn="ctr"/>
+            <a:endParaRPr/>
           </a:p>
         </p:txBody>
       </p:sp>
@@ -10419,7 +10574,7 @@
         </p:nvSpPr>
         <p:spPr>
           <a:xfrm>
-            <a:off x="1828800" y="4480559"/>
+            <a:off x="1828800" y="3931919"/>
             <a:ext cx="4572000" cy="457200"/>
           </a:xfrm>
           <a:prstGeom prst="rect">
@@ -10455,7 +10610,7 @@
         </p:nvSpPr>
         <p:spPr>
           <a:xfrm>
-            <a:off x="1828800" y="4937759"/>
+            <a:off x="1828800" y="4389119"/>
             <a:ext cx="10058400" cy="640080"/>
           </a:xfrm>
           <a:prstGeom prst="rect">
@@ -10495,7 +10650,7 @@
         </p:nvSpPr>
         <p:spPr>
           <a:xfrm>
-            <a:off x="1371600" y="6035040"/>
+            <a:off x="1371600" y="5486400"/>
             <a:ext cx="11887200" cy="1463040"/>
           </a:xfrm>
           <a:prstGeom prst="roundRect">
@@ -10527,6 +10682,7 @@
           <a:lstStyle/>
           <a:p>
             <a:pPr algn="ctr"/>
+            <a:endParaRPr/>
           </a:p>
         </p:txBody>
       </p:sp>
@@ -10538,7 +10694,7 @@
         </p:nvSpPr>
         <p:spPr>
           <a:xfrm>
-            <a:off x="1371600" y="6035040"/>
+            <a:off x="1371600" y="5486400"/>
             <a:ext cx="54864" cy="1463040"/>
           </a:xfrm>
           <a:prstGeom prst="rect">
@@ -10570,6 +10726,7 @@
           <a:lstStyle/>
           <a:p>
             <a:pPr algn="ctr"/>
+            <a:endParaRPr/>
           </a:p>
         </p:txBody>
       </p:sp>
@@ -10581,7 +10738,7 @@
         </p:nvSpPr>
         <p:spPr>
           <a:xfrm>
-            <a:off x="1828800" y="6217920"/>
+            <a:off x="1828800" y="5669280"/>
             <a:ext cx="4572000" cy="457200"/>
           </a:xfrm>
           <a:prstGeom prst="rect">
@@ -10617,7 +10774,7 @@
         </p:nvSpPr>
         <p:spPr>
           <a:xfrm>
-            <a:off x="1828800" y="6675120"/>
+            <a:off x="1828800" y="6126480"/>
             <a:ext cx="10058400" cy="640080"/>
           </a:xfrm>
           <a:prstGeom prst="rect">
@@ -10657,7 +10814,7 @@
         </p:nvSpPr>
         <p:spPr>
           <a:xfrm>
-            <a:off x="1371600" y="7498079"/>
+            <a:off x="1371600" y="6949439"/>
             <a:ext cx="11887200" cy="365760"/>
           </a:xfrm>
           <a:prstGeom prst="rect">
@@ -10694,7 +10851,7 @@
 </file>
 
 <file path=ppt/slides/slide9.xml><?xml version="1.0" encoding="utf-8"?>
-<p:sld xmlns:a="http://schemas.openxmlformats.org/drawingml/2006/main" xmlns:p="http://schemas.openxmlformats.org/presentationml/2006/main" xmlns:r="http://schemas.openxmlformats.org/officeDocument/2006/relationships">
+<p:sld xmlns:a="http://schemas.openxmlformats.org/drawingml/2006/main" xmlns:r="http://schemas.openxmlformats.org/officeDocument/2006/relationships" xmlns:p="http://schemas.openxmlformats.org/presentationml/2006/main">
   <p:cSld>
     <p:bg>
       <p:bgPr>
@@ -10710,7 +10867,14 @@
         <p:cNvGrpSpPr/>
         <p:nvPr/>
       </p:nvGrpSpPr>
-      <p:grpSpPr/>
+      <p:grpSpPr>
+        <a:xfrm>
+          <a:off x="0" y="0"/>
+          <a:ext cx="0" cy="0"/>
+          <a:chOff x="0" y="0"/>
+          <a:chExt cx="0" cy="0"/>
+        </a:xfrm>
+      </p:grpSpPr>
       <p:sp>
         <p:nvSpPr>
           <p:cNvPr id="2" name="TextBox 1"/>
@@ -10791,7 +10955,7 @@
         </p:nvSpPr>
         <p:spPr>
           <a:xfrm>
-            <a:off x="1371600" y="2560320"/>
+            <a:off x="1371600" y="2194559"/>
             <a:ext cx="11887200" cy="1280160"/>
           </a:xfrm>
           <a:prstGeom prst="roundRect">
@@ -10823,6 +10987,7 @@
           <a:lstStyle/>
           <a:p>
             <a:pPr algn="ctr"/>
+            <a:endParaRPr/>
           </a:p>
         </p:txBody>
       </p:sp>
@@ -10834,7 +10999,7 @@
         </p:nvSpPr>
         <p:spPr>
           <a:xfrm>
-            <a:off x="1828800" y="2697479"/>
+            <a:off x="1828800" y="2331718"/>
             <a:ext cx="3657600" cy="457200"/>
           </a:xfrm>
           <a:prstGeom prst="rect">
@@ -10870,7 +11035,7 @@
         </p:nvSpPr>
         <p:spPr>
           <a:xfrm>
-            <a:off x="5943600" y="2697479"/>
+            <a:off x="5943600" y="2331718"/>
             <a:ext cx="6858000" cy="1005840"/>
           </a:xfrm>
           <a:prstGeom prst="rect">
@@ -10910,7 +11075,7 @@
         </p:nvSpPr>
         <p:spPr>
           <a:xfrm>
-            <a:off x="1371600" y="4114800"/>
+            <a:off x="1371600" y="3749039"/>
             <a:ext cx="11887200" cy="1280160"/>
           </a:xfrm>
           <a:prstGeom prst="roundRect">
@@ -10942,6 +11107,7 @@
           <a:lstStyle/>
           <a:p>
             <a:pPr algn="ctr"/>
+            <a:endParaRPr/>
           </a:p>
         </p:txBody>
       </p:sp>
@@ -10953,7 +11119,7 @@
         </p:nvSpPr>
         <p:spPr>
           <a:xfrm>
-            <a:off x="1828800" y="4251960"/>
+            <a:off x="1828800" y="3886199"/>
             <a:ext cx="3657600" cy="457200"/>
           </a:xfrm>
           <a:prstGeom prst="rect">
@@ -10989,7 +11155,7 @@
         </p:nvSpPr>
         <p:spPr>
           <a:xfrm>
-            <a:off x="5943600" y="4251960"/>
+            <a:off x="5943600" y="3886199"/>
             <a:ext cx="6858000" cy="1005840"/>
           </a:xfrm>
           <a:prstGeom prst="rect">
@@ -11029,7 +11195,7 @@
         </p:nvSpPr>
         <p:spPr>
           <a:xfrm>
-            <a:off x="1371600" y="5669279"/>
+            <a:off x="1371600" y="5303518"/>
             <a:ext cx="11887200" cy="1280160"/>
           </a:xfrm>
           <a:prstGeom prst="roundRect">
@@ -11061,6 +11227,7 @@
           <a:lstStyle/>
           <a:p>
             <a:pPr algn="ctr"/>
+            <a:endParaRPr/>
           </a:p>
         </p:txBody>
       </p:sp>
@@ -11072,7 +11239,7 @@
         </p:nvSpPr>
         <p:spPr>
           <a:xfrm>
-            <a:off x="1828800" y="5806440"/>
+            <a:off x="1828800" y="5440679"/>
             <a:ext cx="3657600" cy="457200"/>
           </a:xfrm>
           <a:prstGeom prst="rect">
@@ -11108,7 +11275,7 @@
         </p:nvSpPr>
         <p:spPr>
           <a:xfrm>
-            <a:off x="5943600" y="5806440"/>
+            <a:off x="5943600" y="5440679"/>
             <a:ext cx="6858000" cy="1005840"/>
           </a:xfrm>
           <a:prstGeom prst="rect">
@@ -11148,7 +11315,7 @@
         </p:nvSpPr>
         <p:spPr>
           <a:xfrm>
-            <a:off x="1371600" y="6949440"/>
+            <a:off x="1371600" y="6583679"/>
             <a:ext cx="11887200" cy="731520"/>
           </a:xfrm>
           <a:prstGeom prst="roundRect">
@@ -11180,6 +11347,7 @@
           <a:lstStyle/>
           <a:p>
             <a:pPr algn="ctr"/>
+            <a:endParaRPr/>
           </a:p>
         </p:txBody>
       </p:sp>
@@ -11191,7 +11359,7 @@
         </p:nvSpPr>
         <p:spPr>
           <a:xfrm>
-            <a:off x="1828800" y="7040880"/>
+            <a:off x="1828800" y="6675119"/>
             <a:ext cx="2743200" cy="274320"/>
           </a:xfrm>
           <a:prstGeom prst="rect">
@@ -11227,7 +11395,7 @@
         </p:nvSpPr>
         <p:spPr>
           <a:xfrm>
-            <a:off x="1828800" y="7315200"/>
+            <a:off x="1828800" y="6949439"/>
             <a:ext cx="5486400" cy="274320"/>
           </a:xfrm>
           <a:prstGeom prst="rect">
@@ -11263,7 +11431,7 @@
         </p:nvSpPr>
         <p:spPr>
           <a:xfrm>
-            <a:off x="9144000" y="7086600"/>
+            <a:off x="9144000" y="6720839"/>
             <a:ext cx="3657600" cy="457200"/>
           </a:xfrm>
           <a:prstGeom prst="rect">

</xml_diff>